<commit_message>
fix digits of pi question + previously unsaved work
</commit_message>
<xml_diff>
--- a/HourGuard Final Presentation Video.pptx
+++ b/HourGuard Final Presentation Video.pptx
@@ -410,7 +410,7 @@
             <a:fld id="{08B9EBBA-996F-894A-B54A-D6246ED52CEA}" type="datetimeFigureOut">
               <a:rPr lang="en-US" dirty="0"/>
               <a:pPr/>
-              <a:t>3/26/2026</a:t>
+              <a:t>3/29/2026</a:t>
             </a:fld>
             <a:endParaRPr lang="en-US"/>
           </a:p>
@@ -725,7 +725,7 @@
             <a:fld id="{18C79C5D-2A6F-F04D-97DA-BEF2467B64E4}" type="datetimeFigureOut">
               <a:rPr lang="en-US" dirty="0"/>
               <a:pPr/>
-              <a:t>3/26/2026</a:t>
+              <a:t>3/29/2026</a:t>
             </a:fld>
             <a:endParaRPr lang="en-US"/>
           </a:p>
@@ -1214,7 +1214,7 @@
             <a:fld id="{8DFA1846-DA80-1C48-A609-854EA85C59AD}" type="datetimeFigureOut">
               <a:rPr lang="en-US" dirty="0"/>
               <a:pPr/>
-              <a:t>3/26/2026</a:t>
+              <a:t>3/29/2026</a:t>
             </a:fld>
             <a:endParaRPr lang="en-US"/>
           </a:p>
@@ -1584,7 +1584,7 @@
             <a:fld id="{FBF54567-0DE4-3F47-BF90-CB84690072F9}" type="datetimeFigureOut">
               <a:rPr lang="en-US" dirty="0"/>
               <a:pPr/>
-              <a:t>3/26/2026</a:t>
+              <a:t>3/29/2026</a:t>
             </a:fld>
             <a:endParaRPr lang="en-US"/>
           </a:p>
@@ -1857,7 +1857,7 @@
             <a:fld id="{C6C52C72-DE31-F449-A4ED-4C594FD91407}" type="datetimeFigureOut">
               <a:rPr lang="en-US" dirty="0"/>
               <a:pPr/>
-              <a:t>3/26/2026</a:t>
+              <a:t>3/29/2026</a:t>
             </a:fld>
             <a:endParaRPr lang="en-US"/>
           </a:p>
@@ -2142,7 +2142,7 @@
             <a:fld id="{ED62726E-379B-B349-9EED-81ED093FA806}" type="datetimeFigureOut">
               <a:rPr lang="en-US" dirty="0"/>
               <a:pPr/>
-              <a:t>3/26/2026</a:t>
+              <a:t>3/29/2026</a:t>
             </a:fld>
             <a:endParaRPr lang="en-US"/>
           </a:p>
@@ -2425,7 +2425,7 @@
             <a:fld id="{9B3A1323-8D79-1946-B0D7-40001CF92E9D}" type="datetimeFigureOut">
               <a:rPr lang="en-US" dirty="0"/>
               <a:pPr/>
-              <a:t>3/26/2026</a:t>
+              <a:t>3/29/2026</a:t>
             </a:fld>
             <a:endParaRPr lang="en-US"/>
           </a:p>
@@ -2769,7 +2769,7 @@
             <a:fld id="{8DFA1846-DA80-1C48-A609-854EA85C59AD}" type="datetimeFigureOut">
               <a:rPr lang="en-US" dirty="0"/>
               <a:pPr/>
-              <a:t>3/26/2026</a:t>
+              <a:t>3/29/2026</a:t>
             </a:fld>
             <a:endParaRPr lang="en-US"/>
           </a:p>
@@ -3107,7 +3107,7 @@
             <a:fld id="{57302355-E14B-8545-A8F8-0FE83CC9D524}" type="datetimeFigureOut">
               <a:rPr lang="en-US" dirty="0"/>
               <a:pPr/>
-              <a:t>3/26/2026</a:t>
+              <a:t>3/29/2026</a:t>
             </a:fld>
             <a:endParaRPr lang="en-US"/>
           </a:p>
@@ -3583,7 +3583,7 @@
             <a:fld id="{02640F58-564D-2B4F-AE67-E407BA4FCF45}" type="datetimeFigureOut">
               <a:rPr lang="en-US" dirty="0"/>
               <a:pPr/>
-              <a:t>3/26/2026</a:t>
+              <a:t>3/29/2026</a:t>
             </a:fld>
             <a:endParaRPr lang="en-US"/>
           </a:p>
@@ -3805,7 +3805,7 @@
             <a:fld id="{F13A34C8-038E-2045-AF43-DF7DBB8E0E9E}" type="datetimeFigureOut">
               <a:rPr lang="en-US" dirty="0"/>
               <a:pPr/>
-              <a:t>3/26/2026</a:t>
+              <a:t>3/29/2026</a:t>
             </a:fld>
             <a:endParaRPr lang="en-US"/>
           </a:p>
@@ -3902,7 +3902,7 @@
             <a:fld id="{8818C68F-D26B-8F47-958C-23B49CF8A634}" type="datetimeFigureOut">
               <a:rPr lang="en-US" dirty="0"/>
               <a:pPr/>
-              <a:t>3/26/2026</a:t>
+              <a:t>3/29/2026</a:t>
             </a:fld>
             <a:endParaRPr lang="en-US"/>
           </a:p>
@@ -4369,7 +4369,7 @@
             <a:fld id="{D0DF5E60-9974-AC48-9591-99C2BB44B7CF}" type="datetimeFigureOut">
               <a:rPr lang="en-US" dirty="0"/>
               <a:pPr/>
-              <a:t>3/26/2026</a:t>
+              <a:t>3/29/2026</a:t>
             </a:fld>
             <a:endParaRPr lang="en-US"/>
           </a:p>
@@ -4679,7 +4679,7 @@
             <a:fld id="{18C79C5D-2A6F-F04D-97DA-BEF2467B64E4}" type="datetimeFigureOut">
               <a:rPr lang="en-US" dirty="0"/>
               <a:pPr/>
-              <a:t>3/26/2026</a:t>
+              <a:t>3/29/2026</a:t>
             </a:fld>
             <a:endParaRPr lang="en-US"/>
           </a:p>
@@ -4949,7 +4949,7 @@
             <a:fld id="{09B482E8-6E0E-1B4F-B1FD-C69DB9E858D9}" type="datetimeFigureOut">
               <a:rPr lang="en-US" dirty="0"/>
               <a:pPr/>
-              <a:t>3/26/2026</a:t>
+              <a:t>3/29/2026</a:t>
             </a:fld>
             <a:endParaRPr lang="en-US"/>
           </a:p>
@@ -5456,10 +5456,10 @@
           <p:nvPr/>
         </p:nvPicPr>
         <p:blipFill>
-          <a:blip r:embed="rId2">
+          <a:blip>
             <a:extLst>
               <a:ext uri="{96DAC541-7B7A-43D3-8B79-37D633B846F1}">
-                <asvg:svgBlip xmlns:asvg="http://schemas.microsoft.com/office/drawing/2016/SVG/main" r:embed="rId3"/>
+                <asvg:svgBlip xmlns:asvg="http://schemas.microsoft.com/office/drawing/2016/SVG/main" r:embed="rId2"/>
               </a:ext>
             </a:extLst>
           </a:blip>
@@ -5616,10 +5616,10 @@
           <p:nvPr/>
         </p:nvPicPr>
         <p:blipFill>
-          <a:blip r:embed="rId2">
+          <a:blip>
             <a:extLst>
               <a:ext uri="{96DAC541-7B7A-43D3-8B79-37D633B846F1}">
-                <asvg:svgBlip xmlns:asvg="http://schemas.microsoft.com/office/drawing/2016/SVG/main" r:embed="rId3"/>
+                <asvg:svgBlip xmlns:asvg="http://schemas.microsoft.com/office/drawing/2016/SVG/main" r:embed="rId2"/>
               </a:ext>
             </a:extLst>
           </a:blip>
@@ -5791,7 +5791,14 @@
             <a:pPr lvl="1"/>
             <a:r>
               <a:rPr lang="en-US" sz="2000" dirty="0"/>
-              <a:t>Streaks for staying within set app limits provide positive reinforcement</a:t>
+              <a:t>Streaks for staying within set app limits provide </a:t>
+            </a:r>
+            <a:br>
+              <a:rPr lang="en-US" sz="2000" dirty="0"/>
+            </a:br>
+            <a:r>
+              <a:rPr lang="en-US" sz="2000" dirty="0"/>
+              <a:t>positive reinforcement</a:t>
             </a:r>
           </a:p>
         </p:txBody>
@@ -5811,10 +5818,10 @@
           <p:nvPr/>
         </p:nvPicPr>
         <p:blipFill>
-          <a:blip r:embed="rId2">
+          <a:blip>
             <a:extLst>
               <a:ext uri="{96DAC541-7B7A-43D3-8B79-37D633B846F1}">
-                <asvg:svgBlip xmlns:asvg="http://schemas.microsoft.com/office/drawing/2016/SVG/main" r:embed="rId3"/>
+                <asvg:svgBlip xmlns:asvg="http://schemas.microsoft.com/office/drawing/2016/SVG/main" r:embed="rId2"/>
               </a:ext>
             </a:extLst>
           </a:blip>
@@ -5911,10 +5918,10 @@
           <p:nvPr/>
         </p:nvPicPr>
         <p:blipFill>
-          <a:blip r:embed="rId2">
+          <a:blip>
             <a:extLst>
               <a:ext uri="{96DAC541-7B7A-43D3-8B79-37D633B846F1}">
-                <asvg:svgBlip xmlns:asvg="http://schemas.microsoft.com/office/drawing/2016/SVG/main" r:embed="rId3"/>
+                <asvg:svgBlip xmlns:asvg="http://schemas.microsoft.com/office/drawing/2016/SVG/main" r:embed="rId2"/>
               </a:ext>
             </a:extLst>
           </a:blip>
@@ -5946,8 +5953,8 @@
         </p:nvSpPr>
         <p:spPr>
           <a:xfrm>
-            <a:off x="2609757" y="2727318"/>
-            <a:ext cx="9193174" cy="3323760"/>
+            <a:off x="3192691" y="2291462"/>
+            <a:ext cx="8189307" cy="2960815"/>
           </a:xfrm>
           <a:prstGeom prst="roundRect">
             <a:avLst>
@@ -6001,10 +6008,10 @@
           <p:nvPr/>
         </p:nvPicPr>
         <p:blipFill>
-          <a:blip r:embed="rId4">
+          <a:blip>
             <a:extLst>
               <a:ext uri="{96DAC541-7B7A-43D3-8B79-37D633B846F1}">
-                <asvg:svgBlip xmlns:asvg="http://schemas.microsoft.com/office/drawing/2016/SVG/main" r:embed="rId5"/>
+                <asvg:svgBlip xmlns:asvg="http://schemas.microsoft.com/office/drawing/2016/SVG/main" r:embed="rId3"/>
               </a:ext>
             </a:extLst>
           </a:blip>
@@ -6014,8 +6021,8 @@
         </p:blipFill>
         <p:spPr>
           <a:xfrm>
-            <a:off x="2849373" y="2958641"/>
-            <a:ext cx="8713938" cy="2833440"/>
+            <a:off x="3432307" y="2522785"/>
+            <a:ext cx="7762402" cy="2524037"/>
           </a:xfrm>
           <a:prstGeom prst="rect">
             <a:avLst/>
@@ -6037,10 +6044,10 @@
           <p:nvPr/>
         </p:nvPicPr>
         <p:blipFill>
-          <a:blip r:embed="rId6">
+          <a:blip>
             <a:extLst>
               <a:ext uri="{96DAC541-7B7A-43D3-8B79-37D633B846F1}">
-                <asvg:svgBlip xmlns:asvg="http://schemas.microsoft.com/office/drawing/2016/SVG/main" r:embed="rId7"/>
+                <asvg:svgBlip xmlns:asvg="http://schemas.microsoft.com/office/drawing/2016/SVG/main" r:embed="rId4"/>
               </a:ext>
             </a:extLst>
           </a:blip>
@@ -6050,7 +6057,7 @@
         </p:blipFill>
         <p:spPr>
           <a:xfrm>
-            <a:off x="628689" y="4168492"/>
+            <a:off x="913059" y="3950690"/>
             <a:ext cx="1364245" cy="798801"/>
           </a:xfrm>
           <a:prstGeom prst="rect">
@@ -6073,10 +6080,10 @@
           <p:nvPr/>
         </p:nvPicPr>
         <p:blipFill>
-          <a:blip r:embed="rId8">
+          <a:blip>
             <a:extLst>
               <a:ext uri="{96DAC541-7B7A-43D3-8B79-37D633B846F1}">
-                <asvg:svgBlip xmlns:asvg="http://schemas.microsoft.com/office/drawing/2016/SVG/main" r:embed="rId9"/>
+                <asvg:svgBlip xmlns:asvg="http://schemas.microsoft.com/office/drawing/2016/SVG/main" r:embed="rId5"/>
               </a:ext>
             </a:extLst>
           </a:blip>
@@ -6086,7 +6093,7 @@
         </p:blipFill>
         <p:spPr>
           <a:xfrm>
-            <a:off x="421586" y="5252277"/>
+            <a:off x="710633" y="5252276"/>
             <a:ext cx="1769096" cy="798801"/>
           </a:xfrm>
           <a:prstGeom prst="rect">
@@ -6109,7 +6116,7 @@
           <p:nvPr/>
         </p:nvPicPr>
         <p:blipFill>
-          <a:blip r:embed="rId10">
+          <a:blip r:embed="rId6">
             <a:extLst>
               <a:ext uri="{28A0092B-C50C-407E-A947-70E740481C1C}">
                 <a14:useLocalDpi xmlns:a14="http://schemas.microsoft.com/office/drawing/2010/main" val="0"/>
@@ -6122,7 +6129,7 @@
         </p:blipFill>
         <p:spPr>
           <a:xfrm>
-            <a:off x="728039" y="2727318"/>
+            <a:off x="1017086" y="2291715"/>
             <a:ext cx="1156190" cy="1156190"/>
           </a:xfrm>
           <a:prstGeom prst="rect">
@@ -6213,10 +6220,10 @@
           <p:nvPr/>
         </p:nvPicPr>
         <p:blipFill>
-          <a:blip r:embed="rId2">
+          <a:blip>
             <a:extLst>
               <a:ext uri="{96DAC541-7B7A-43D3-8B79-37D633B846F1}">
-                <asvg:svgBlip xmlns:asvg="http://schemas.microsoft.com/office/drawing/2016/SVG/main" r:embed="rId3"/>
+                <asvg:svgBlip xmlns:asvg="http://schemas.microsoft.com/office/drawing/2016/SVG/main" r:embed="rId2"/>
               </a:ext>
             </a:extLst>
           </a:blip>
@@ -6248,8 +6255,8 @@
         </p:nvSpPr>
         <p:spPr>
           <a:xfrm>
-            <a:off x="4591047" y="2139200"/>
-            <a:ext cx="3009904" cy="4368352"/>
+            <a:off x="5093032" y="2867744"/>
+            <a:ext cx="2005934" cy="2911264"/>
           </a:xfrm>
           <a:prstGeom prst="roundRect">
             <a:avLst>
@@ -6257,7 +6264,7 @@
             </a:avLst>
           </a:prstGeom>
           <a:blipFill dpi="0" rotWithShape="1">
-            <a:blip r:embed="rId4" cstate="print">
+            <a:blip r:embed="rId3" cstate="print">
               <a:extLst>
                 <a:ext uri="{28A0092B-C50C-407E-A947-70E740481C1C}">
                   <a14:useLocalDpi xmlns:a14="http://schemas.microsoft.com/office/drawing/2010/main" val="0"/>
@@ -6454,10 +6461,10 @@
           <p:nvPr/>
         </p:nvPicPr>
         <p:blipFill>
-          <a:blip r:embed="rId2">
+          <a:blip>
             <a:extLst>
               <a:ext uri="{96DAC541-7B7A-43D3-8B79-37D633B846F1}">
-                <asvg:svgBlip xmlns:asvg="http://schemas.microsoft.com/office/drawing/2016/SVG/main" r:embed="rId3"/>
+                <asvg:svgBlip xmlns:asvg="http://schemas.microsoft.com/office/drawing/2016/SVG/main" r:embed="rId2"/>
               </a:ext>
             </a:extLst>
           </a:blip>

</xml_diff>